<commit_message>
W02 D4 humanizer pass: staged closers, aphorisms and clipped contrasts rewritten in the decks, the notebooks (through the builder), the notes and the lab solution
Also: the deck's S48 note no longer calls a paraphrase Kavya's words
word for word; half two's cover takes a one-line quote so its wrapped
chapter strip clears the footer; 'actually' leaves chapter 3's member-
months question in the deck, notebook and notes; both decks rebuilt and
the five changed notebooks re-executed.

Co-Authored-By: Claude Opus 5.5 <noreply@anthropic.com>
Claude-Session: https://claude.ai/code/session_01UGBvesxPUUhP16goWgthnA
</commit_message>
<xml_diff>
--- a/content/W02/D4/slides/C2_W02_D04_half2_STUDENT.pptx
+++ b/content/W02/D4/slides/C2_W02_D04_half2_STUDENT.pptx
@@ -851,12 +851,12 @@
           <a:lstStyle/>
           <a:p>
             <a:r>
-              <a:t>LIVE, 3 minutes. Each guard is compared with a number the warehouse gives on its own, never a number</a:t>
-            </a:r>
-          </a:p>
-          <a:p>
-            <a:r>
-              <a:t>the notebook computed, which is what makes it a guard.</a:t>
+              <a:t>LIVE, 3 minutes. Each guard is compared with a number the warehouse gives on its own, so a slip in the</a:t>
+            </a:r>
+          </a:p>
+          <a:p>
+            <a:r>
+              <a:t>notebook cannot pass its own check.</a:t>
             </a:r>
           </a:p>
         </p:txBody>
@@ -926,7 +926,7 @@
           <a:lstStyle/>
           <a:p>
             <a:r>
-              <a:t>LIVE, 2 minutes. A guard is proved the only way a guard can be: by making it fire.</a:t>
+              <a:t>LIVE, 2 minutes. Prove each guard by making it fire on a copy broken on purpose.</a:t>
             </a:r>
           </a:p>
         </p:txBody>
@@ -6414,7 +6414,7 @@
                 </a:solidFill>
                 <a:latin typeface="Georgia"/>
               </a:rPr>
-              <a:t>Will the Monday table rebuild itself and hold?</a:t>
+              <a:t>Will Monday's table rebuild itself and hold?</a:t>
             </a:r>
           </a:p>
         </p:txBody>
@@ -6428,7 +6428,7 @@
         <p:spPr>
           <a:xfrm>
             <a:off x="621792" y="4263136"/>
-            <a:ext cx="10033711" cy="977645"/>
+            <a:ext cx="10033711" cy="663956"/>
           </a:xfrm>
           <a:prstGeom prst="rect">
             <a:avLst/>
@@ -6449,7 +6449,7 @@
                 </a:solidFill>
                 <a:latin typeface="Georgia"/>
               </a:rPr>
-              <a:t>“The warehouse queries are fine for Finance, but Marketing's analysts live in Python. Build them the table in pandas, from the warehouse, and make it refreshable in one run.”</a:t>
+              <a:t>“Build them the table in pandas, from the warehouse, and make it refreshable in one run.”</a:t>
             </a:r>
           </a:p>
         </p:txBody>
@@ -6462,7 +6462,7 @@
         </p:nvSpPr>
         <p:spPr>
           <a:xfrm>
-            <a:off x="621792" y="5295646"/>
+            <a:off x="621792" y="4981956"/>
             <a:ext cx="10033711" cy="218186"/>
           </a:xfrm>
           <a:prstGeom prst="rect">
@@ -6497,7 +6497,7 @@
         </p:nvSpPr>
         <p:spPr>
           <a:xfrm>
-            <a:off x="621792" y="5833872"/>
+            <a:off x="621792" y="5520182"/>
             <a:ext cx="365760" cy="251205"/>
           </a:xfrm>
           <a:prstGeom prst="rect">
@@ -6532,7 +6532,7 @@
         </p:nvSpPr>
         <p:spPr>
           <a:xfrm>
-            <a:off x="1005839" y="5870448"/>
+            <a:off x="1005839" y="5556758"/>
             <a:ext cx="1543335" cy="185166"/>
           </a:xfrm>
           <a:prstGeom prst="rect">
@@ -6567,7 +6567,7 @@
         </p:nvSpPr>
         <p:spPr>
           <a:xfrm>
-            <a:off x="2732055" y="5833872"/>
+            <a:off x="2732055" y="5520182"/>
             <a:ext cx="365760" cy="251205"/>
           </a:xfrm>
           <a:prstGeom prst="rect">
@@ -6602,7 +6602,7 @@
         </p:nvSpPr>
         <p:spPr>
           <a:xfrm>
-            <a:off x="3116103" y="5870448"/>
+            <a:off x="3116103" y="5556758"/>
             <a:ext cx="1543335" cy="185166"/>
           </a:xfrm>
           <a:prstGeom prst="rect">
@@ -6637,7 +6637,7 @@
         </p:nvSpPr>
         <p:spPr>
           <a:xfrm>
-            <a:off x="4842319" y="5833872"/>
+            <a:off x="4842319" y="5520182"/>
             <a:ext cx="365760" cy="251205"/>
           </a:xfrm>
           <a:prstGeom prst="rect">
@@ -6672,7 +6672,7 @@
         </p:nvSpPr>
         <p:spPr>
           <a:xfrm>
-            <a:off x="5226367" y="5870448"/>
+            <a:off x="5226367" y="5556758"/>
             <a:ext cx="1839087" cy="185166"/>
           </a:xfrm>
           <a:prstGeom prst="rect">
@@ -6707,7 +6707,7 @@
         </p:nvSpPr>
         <p:spPr>
           <a:xfrm>
-            <a:off x="7248334" y="5833872"/>
+            <a:off x="7248334" y="5520182"/>
             <a:ext cx="365760" cy="251205"/>
           </a:xfrm>
           <a:prstGeom prst="rect">
@@ -6742,7 +6742,7 @@
         </p:nvSpPr>
         <p:spPr>
           <a:xfrm>
-            <a:off x="7632382" y="5870448"/>
+            <a:off x="7632382" y="5556758"/>
             <a:ext cx="1720786" cy="185166"/>
           </a:xfrm>
           <a:prstGeom prst="rect">
@@ -6777,7 +6777,7 @@
         </p:nvSpPr>
         <p:spPr>
           <a:xfrm>
-            <a:off x="621792" y="6254496"/>
+            <a:off x="621792" y="5940806"/>
             <a:ext cx="365760" cy="251205"/>
           </a:xfrm>
           <a:prstGeom prst="rect">
@@ -6812,7 +6812,7 @@
         </p:nvSpPr>
         <p:spPr>
           <a:xfrm>
-            <a:off x="1005839" y="6291072"/>
+            <a:off x="1005839" y="5977382"/>
             <a:ext cx="1779936" cy="185166"/>
           </a:xfrm>
           <a:prstGeom prst="rect">
@@ -6847,7 +6847,7 @@
         </p:nvSpPr>
         <p:spPr>
           <a:xfrm>
-            <a:off x="2968656" y="6254496"/>
+            <a:off x="2968656" y="5940806"/>
             <a:ext cx="365760" cy="251205"/>
           </a:xfrm>
           <a:prstGeom prst="rect">
@@ -6882,7 +6882,7 @@
         </p:nvSpPr>
         <p:spPr>
           <a:xfrm>
-            <a:off x="3352704" y="6291072"/>
+            <a:off x="3352704" y="5977382"/>
             <a:ext cx="1898237" cy="185166"/>
           </a:xfrm>
           <a:prstGeom prst="rect">
@@ -6939,7 +6939,7 @@
                 </a:solidFill>
                 <a:latin typeface="Calibri"/>
               </a:rPr>
-              <a:t>Week 2, Day 4. Will the Monday table rebuild itself and hold?</a:t>
+              <a:t>Week 2, Day 4. Will Monday's table rebuild itself and hold?</a:t>
             </a:r>
           </a:p>
         </p:txBody>
@@ -13531,7 +13531,7 @@
                 </a:solidFill>
                 <a:latin typeface="Calibri"/>
               </a:rPr>
-              <a:t>Nothing, which is the point: every broken copy trips a guard, and the honest one trips none.</a:t>
+              <a:t>Nothing ships broken: every broken copy trips a guard, and the honest table trips none.</a:t>
             </a:r>
           </a:p>
         </p:txBody>
@@ -18536,7 +18536,7 @@
                 </a:solidFill>
                 <a:latin typeface="Calibri"/>
               </a:rPr>
-              <a:t>Week 2, Day 4. Will the Monday table rebuild itself and hold?</a:t>
+              <a:t>Week 2, Day 4. Will Monday's table rebuild itself and hold?</a:t>
             </a:r>
           </a:p>
         </p:txBody>
@@ -19212,7 +19212,7 @@
                 </a:solidFill>
                 <a:latin typeface="Calibri"/>
               </a:rPr>
-              <a:t>Week 2, Day 4. Will the Monday table rebuild itself and hold?</a:t>
+              <a:t>Week 2, Day 4. Will Monday's table rebuild itself and hold?</a:t>
             </a:r>
           </a:p>
         </p:txBody>
@@ -23064,7 +23064,7 @@
                 </a:solidFill>
                 <a:latin typeface="Calibri"/>
               </a:rPr>
-              <a:t>Week 2, Day 4. Will the Monday table rebuild itself and hold?</a:t>
+              <a:t>Week 2, Day 4. Will Monday's table rebuild itself and hold?</a:t>
             </a:r>
           </a:p>
         </p:txBody>
@@ -26405,7 +26405,7 @@
                 </a:solidFill>
                 <a:latin typeface="Calibri"/>
               </a:rPr>
-              <a:t>Week 2, Day 4. Will the Monday table rebuild itself and hold?</a:t>
+              <a:t>Week 2, Day 4. Will Monday's table rebuild itself and hold?</a:t>
             </a:r>
           </a:p>
         </p:txBody>
@@ -31135,7 +31135,7 @@
                 </a:solidFill>
                 <a:latin typeface="Calibri"/>
               </a:rPr>
-              <a:t>Week 2, Day 4. Will the Monday table rebuild itself and hold?</a:t>
+              <a:t>Week 2, Day 4. Will Monday's table rebuild itself and hold?</a:t>
             </a:r>
           </a:p>
         </p:txBody>
@@ -36186,7 +36186,7 @@
                 </a:solidFill>
                 <a:latin typeface="Calibri"/>
               </a:rPr>
-              <a:t>Week 2, Day 4. Will the Monday table rebuild itself and hold?</a:t>
+              <a:t>Week 2, Day 4. Will Monday's table rebuild itself and hold?</a:t>
             </a:r>
           </a:p>
         </p:txBody>
@@ -41413,7 +41413,7 @@
                 </a:solidFill>
                 <a:latin typeface="Calibri"/>
               </a:rPr>
-              <a:t>A refresh that never counts rows in against rows out loses them without a sound, and a week of decisions rests on the short number.</a:t>
+              <a:t>A refresh that never counts rows in against rows out loses them without an error, and a week of decisions rests on the short number.</a:t>
             </a:r>
           </a:p>
         </p:txBody>

</xml_diff>